<commit_message>
chore: EOD 2026-07-22 — Santa's Wonderland vision slide, boot resume, plaud-ingest correction, git-skill correction
- Added vision slide to Santa's Wonderland Discovery Proposal deck
- Resumed and completed stalled boot workflow (2026-07-21 session)
- Corrected plaud-ingest stale-abort report (err-20260722T164142-KOFUWY), re-ran live via Knox, 2 recordings ingested
- Verified golf-booking fix and shutdown-cleanup lock clearance
- Logged git-skill bypass correction (err-20260722T182653-2LCKRB) and switched to Desktop Commander per skills/git/SKILL.md
- Closed session-2026-07-17-091548 and session-2026-07-21-142549 in session index
- Rated scheduled daily-review eval run (neutral/3)
</commit_message>
<xml_diff>
--- a/accounts/Santa's Wonderland/Santa's Wonderland - Discovery Proposal July 2026 - DOH.pptx
+++ b/accounts/Santa's Wonderland/Santa's Wonderland - Discovery Proposal July 2026 - DOH.pptx
@@ -5,63 +5,64 @@
     <p:sldMasterId id="2147483648" r:id="rId4"/>
   </p:sldMasterIdLst>
   <p:notesMasterIdLst>
-    <p:notesMasterId r:id="rId12"/>
+    <p:notesMasterId r:id="rId13"/>
   </p:notesMasterIdLst>
   <p:handoutMasterIdLst>
-    <p:handoutMasterId r:id="rId13"/>
+    <p:handoutMasterId r:id="rId14"/>
   </p:handoutMasterIdLst>
   <p:sldIdLst>
     <p:sldId id="1303" r:id="rId5"/>
     <p:sldId id="355" r:id="rId6"/>
-    <p:sldId id="288" r:id="rId7"/>
-    <p:sldId id="1334" r:id="rId8"/>
-    <p:sldId id="260" r:id="rId9"/>
-    <p:sldId id="261" r:id="rId10"/>
-    <p:sldId id="262" r:id="rId11"/>
+    <p:sldId id="1335" r:id="rId7"/>
+    <p:sldId id="288" r:id="rId8"/>
+    <p:sldId id="1334" r:id="rId9"/>
+    <p:sldId id="260" r:id="rId10"/>
+    <p:sldId id="261" r:id="rId11"/>
+    <p:sldId id="262" r:id="rId12"/>
   </p:sldIdLst>
   <p:sldSz cx="12192000" cy="6858000"/>
   <p:notesSz cx="6858000" cy="9144000"/>
   <p:embeddedFontLst>
     <p:embeddedFont>
       <p:font typeface="Avenir Next Medium" panose="020B0503020202020204" pitchFamily="34" charset="0"/>
-      <p:regular r:id="rId14"/>
-      <p:italic r:id="rId15"/>
+      <p:regular r:id="rId15"/>
+      <p:italic r:id="rId16"/>
     </p:embeddedFont>
     <p:embeddedFont>
       <p:font typeface="Century Gothic" panose="020B0502020202020204" pitchFamily="34" charset="0"/>
-      <p:regular r:id="rId16"/>
-      <p:bold r:id="rId17"/>
-      <p:italic r:id="rId18"/>
-      <p:boldItalic r:id="rId19"/>
+      <p:regular r:id="rId17"/>
+      <p:bold r:id="rId18"/>
+      <p:italic r:id="rId19"/>
+      <p:boldItalic r:id="rId20"/>
     </p:embeddedFont>
     <p:embeddedFont>
       <p:font typeface="Khula" panose="02000000000000000000" pitchFamily="2" charset="0"/>
-      <p:regular r:id="rId20"/>
-      <p:bold r:id="rId21"/>
+      <p:regular r:id="rId21"/>
+      <p:bold r:id="rId22"/>
     </p:embeddedFont>
     <p:embeddedFont>
       <p:font typeface="Khula SemiBold" panose="02000000000000000000" pitchFamily="2" charset="0"/>
-      <p:regular r:id="rId22"/>
-      <p:bold r:id="rId23"/>
+      <p:regular r:id="rId23"/>
+      <p:bold r:id="rId24"/>
     </p:embeddedFont>
     <p:embeddedFont>
       <p:font typeface="Poppins" pitchFamily="2" charset="77"/>
-      <p:regular r:id="rId24"/>
-      <p:bold r:id="rId25"/>
-      <p:italic r:id="rId26"/>
-      <p:boldItalic r:id="rId27"/>
+      <p:regular r:id="rId25"/>
+      <p:bold r:id="rId26"/>
+      <p:italic r:id="rId27"/>
+      <p:boldItalic r:id="rId28"/>
     </p:embeddedFont>
     <p:embeddedFont>
       <p:font typeface="Poppins Medium" panose="00000600000000000000" pitchFamily="2" charset="77"/>
-      <p:regular r:id="rId28"/>
-      <p:italic r:id="rId29"/>
+      <p:regular r:id="rId29"/>
+      <p:italic r:id="rId30"/>
     </p:embeddedFont>
     <p:embeddedFont>
       <p:font typeface="Poppins SemiBold" panose="00000700000000000000" pitchFamily="2" charset="77"/>
-      <p:regular r:id="rId30"/>
-      <p:bold r:id="rId31"/>
-      <p:italic r:id="rId32"/>
-      <p:boldItalic r:id="rId33"/>
+      <p:regular r:id="rId31"/>
+      <p:bold r:id="rId32"/>
+      <p:italic r:id="rId33"/>
+      <p:boldItalic r:id="rId34"/>
     </p:embeddedFont>
   </p:embeddedFontLst>
   <p:defaultTextStyle>
@@ -170,6 +171,7 @@
         <p14:section name="Project Background" id="{BD134884-8502-8A40-8B7D-66C23F2B60D2}">
           <p14:sldIdLst>
             <p14:sldId id="355"/>
+            <p14:sldId id="1335"/>
             <p14:sldId id="288"/>
           </p14:sldIdLst>
         </p14:section>
@@ -224,8 +226,7 @@
 <file path=ppt/revisionInfo.xml><?xml version="1.0" encoding="utf-8"?>
 <p1510:revInfo xmlns:a="http://schemas.openxmlformats.org/drawingml/2006/main" xmlns:r="http://schemas.openxmlformats.org/officeDocument/2006/relationships" xmlns:p1510="http://schemas.microsoft.com/office/powerpoint/2015/10/main">
   <p1510:revLst>
-    <p1510:client id="{65D0D9E3-96C3-2343-B999-FF3C1712A755}" v="764" dt="2026-07-20T17:34:56.003"/>
-    <p1510:client id="{DF3D7635-6338-3A4B-A714-D0F03760C113}" v="1" dt="2026-07-20T20:19:57.182"/>
+    <p1510:client id="{93207E28-D96F-6945-8856-752717EDBEC6}" v="10" dt="2026-07-22T15:51:24.341"/>
   </p1510:revLst>
 </p1510:revInfo>
 </file>
@@ -235,7 +236,7 @@
   <pc:docChgLst>
     <pc:chgData name="David O'Hara" userId="8f90669b-8651-42ab-8d95-20602fbdf8e8" providerId="ADAL" clId="{A236AE32-B983-55C9-B7CE-2378BA1C83AB}"/>
     <pc:docChg chg="custSel modSld modMainMaster">
-      <pc:chgData name="David O'Hara" userId="8f90669b-8651-42ab-8d95-20602fbdf8e8" providerId="ADAL" clId="{A236AE32-B983-55C9-B7CE-2378BA1C83AB}" dt="2026-07-20T21:03:54.320" v="191" actId="20577"/>
+      <pc:chgData name="David O'Hara" userId="8f90669b-8651-42ab-8d95-20602fbdf8e8" providerId="ADAL" clId="{A236AE32-B983-55C9-B7CE-2378BA1C83AB}" dt="2026-07-22T15:51:24.341" v="239" actId="14826"/>
       <pc:docMkLst>
         <pc:docMk/>
       </pc:docMkLst>
@@ -324,14 +325,6 @@
             <ac:spMk id="14" creationId="{00000000-0000-0000-0000-000000000000}"/>
           </ac:spMkLst>
         </pc:spChg>
-        <pc:spChg chg="del">
-          <ac:chgData name="David O'Hara" userId="8f90669b-8651-42ab-8d95-20602fbdf8e8" providerId="ADAL" clId="{A236AE32-B983-55C9-B7CE-2378BA1C83AB}" dt="2026-07-20T21:02:24.024" v="157" actId="478"/>
-          <ac:spMkLst>
-            <pc:docMk/>
-            <pc:sldMk cId="0" sldId="261"/>
-            <ac:spMk id="16" creationId="{00000000-0000-0000-0000-000000000000}"/>
-          </ac:spMkLst>
-        </pc:spChg>
       </pc:sldChg>
       <pc:sldChg chg="modSp mod">
         <pc:chgData name="David O'Hara" userId="8f90669b-8651-42ab-8d95-20602fbdf8e8" providerId="ADAL" clId="{A236AE32-B983-55C9-B7CE-2378BA1C83AB}" dt="2026-07-20T21:03:54.320" v="191" actId="20577"/>
@@ -410,22 +403,6 @@
             <ac:spMk id="2" creationId="{AA275871-7AEF-131B-F4E6-26F4F7861B89}"/>
           </ac:spMkLst>
         </pc:spChg>
-        <pc:spChg chg="add del mod ord">
-          <ac:chgData name="David O'Hara" userId="8f90669b-8651-42ab-8d95-20602fbdf8e8" providerId="ADAL" clId="{A236AE32-B983-55C9-B7CE-2378BA1C83AB}" dt="2026-07-20T20:58:04.874" v="3" actId="6264"/>
-          <ac:spMkLst>
-            <pc:docMk/>
-            <pc:sldMk cId="1451867943" sldId="1334"/>
-            <ac:spMk id="3" creationId="{A821F3E2-B6E1-5DF6-4675-CAF23790AC4D}"/>
-          </ac:spMkLst>
-        </pc:spChg>
-        <pc:spChg chg="add del mod">
-          <ac:chgData name="David O'Hara" userId="8f90669b-8651-42ab-8d95-20602fbdf8e8" providerId="ADAL" clId="{A236AE32-B983-55C9-B7CE-2378BA1C83AB}" dt="2026-07-20T20:58:04.874" v="3" actId="6264"/>
-          <ac:spMkLst>
-            <pc:docMk/>
-            <pc:sldMk cId="1451867943" sldId="1334"/>
-            <ac:spMk id="4" creationId="{7536B25B-8543-00A3-159E-715DF93A0E37}"/>
-          </ac:spMkLst>
-        </pc:spChg>
         <pc:spChg chg="add mod ord">
           <ac:chgData name="David O'Hara" userId="8f90669b-8651-42ab-8d95-20602fbdf8e8" providerId="ADAL" clId="{A236AE32-B983-55C9-B7CE-2378BA1C83AB}" dt="2026-07-20T20:58:04.874" v="3" actId="6264"/>
           <ac:spMkLst>
@@ -434,6 +411,77 @@
             <ac:spMk id="5" creationId="{A6F87D52-FD94-FDC8-26E2-7A32D19DDFFD}"/>
           </ac:spMkLst>
         </pc:spChg>
+      </pc:sldChg>
+      <pc:sldChg chg="addSp delSp modSp mod">
+        <pc:chgData name="David O'Hara" userId="8f90669b-8651-42ab-8d95-20602fbdf8e8" providerId="ADAL" clId="{A236AE32-B983-55C9-B7CE-2378BA1C83AB}" dt="2026-07-22T15:51:24.341" v="239" actId="14826"/>
+        <pc:sldMkLst>
+          <pc:docMk/>
+          <pc:sldMk cId="2650764471" sldId="1335"/>
+        </pc:sldMkLst>
+        <pc:spChg chg="mod">
+          <ac:chgData name="David O'Hara" userId="8f90669b-8651-42ab-8d95-20602fbdf8e8" providerId="ADAL" clId="{A236AE32-B983-55C9-B7CE-2378BA1C83AB}" dt="2026-07-22T15:46:52.602" v="235" actId="6549"/>
+          <ac:spMkLst>
+            <pc:docMk/>
+            <pc:sldMk cId="2650764471" sldId="1335"/>
+            <ac:spMk id="5" creationId="{00000000-0000-0000-0000-000000000000}"/>
+          </ac:spMkLst>
+        </pc:spChg>
+        <pc:spChg chg="del mod">
+          <ac:chgData name="David O'Hara" userId="8f90669b-8651-42ab-8d95-20602fbdf8e8" providerId="ADAL" clId="{A236AE32-B983-55C9-B7CE-2378BA1C83AB}" dt="2026-07-22T15:42:29.803" v="222" actId="478"/>
+          <ac:spMkLst>
+            <pc:docMk/>
+            <pc:sldMk cId="2650764471" sldId="1335"/>
+            <ac:spMk id="11" creationId="{00000000-0000-0000-0000-000000000000}"/>
+          </ac:spMkLst>
+        </pc:spChg>
+        <pc:spChg chg="del">
+          <ac:chgData name="David O'Hara" userId="8f90669b-8651-42ab-8d95-20602fbdf8e8" providerId="ADAL" clId="{A236AE32-B983-55C9-B7CE-2378BA1C83AB}" dt="2026-07-22T15:43:04.234" v="226" actId="478"/>
+          <ac:spMkLst>
+            <pc:docMk/>
+            <pc:sldMk cId="2650764471" sldId="1335"/>
+            <ac:spMk id="12" creationId="{00000000-0000-0000-0000-000000000000}"/>
+          </ac:spMkLst>
+        </pc:spChg>
+        <pc:spChg chg="del">
+          <ac:chgData name="David O'Hara" userId="8f90669b-8651-42ab-8d95-20602fbdf8e8" providerId="ADAL" clId="{A236AE32-B983-55C9-B7CE-2378BA1C83AB}" dt="2026-07-22T15:44:12.065" v="231" actId="478"/>
+          <ac:spMkLst>
+            <pc:docMk/>
+            <pc:sldMk cId="2650764471" sldId="1335"/>
+            <ac:spMk id="13" creationId="{00000000-0000-0000-0000-000000000000}"/>
+          </ac:spMkLst>
+        </pc:spChg>
+        <pc:picChg chg="add mod">
+          <ac:chgData name="David O'Hara" userId="8f90669b-8651-42ab-8d95-20602fbdf8e8" providerId="ADAL" clId="{A236AE32-B983-55C9-B7CE-2378BA1C83AB}" dt="2026-07-22T15:50:54.783" v="237" actId="14826"/>
+          <ac:picMkLst>
+            <pc:docMk/>
+            <pc:sldMk cId="2650764471" sldId="1335"/>
+            <ac:picMk id="8" creationId="{B06CB167-3161-DB07-9101-A592AF12E514}"/>
+          </ac:picMkLst>
+        </pc:picChg>
+        <pc:picChg chg="add mod">
+          <ac:chgData name="David O'Hara" userId="8f90669b-8651-42ab-8d95-20602fbdf8e8" providerId="ADAL" clId="{A236AE32-B983-55C9-B7CE-2378BA1C83AB}" dt="2026-07-22T15:51:07.388" v="238" actId="14826"/>
+          <ac:picMkLst>
+            <pc:docMk/>
+            <pc:sldMk cId="2650764471" sldId="1335"/>
+            <ac:picMk id="9" creationId="{261FB8CE-0914-DBF3-D9C4-7419A6A66A79}"/>
+          </ac:picMkLst>
+        </pc:picChg>
+        <pc:picChg chg="add del mod">
+          <ac:chgData name="David O'Hara" userId="8f90669b-8651-42ab-8d95-20602fbdf8e8" providerId="ADAL" clId="{A236AE32-B983-55C9-B7CE-2378BA1C83AB}" dt="2026-07-22T15:43:51.287" v="229" actId="478"/>
+          <ac:picMkLst>
+            <pc:docMk/>
+            <pc:sldMk cId="2650764471" sldId="1335"/>
+            <ac:picMk id="15" creationId="{DF062078-E3B7-54DD-0400-2BE39A9799F3}"/>
+          </ac:picMkLst>
+        </pc:picChg>
+        <pc:picChg chg="add mod">
+          <ac:chgData name="David O'Hara" userId="8f90669b-8651-42ab-8d95-20602fbdf8e8" providerId="ADAL" clId="{A236AE32-B983-55C9-B7CE-2378BA1C83AB}" dt="2026-07-22T15:51:24.341" v="239" actId="14826"/>
+          <ac:picMkLst>
+            <pc:docMk/>
+            <pc:sldMk cId="2650764471" sldId="1335"/>
+            <ac:picMk id="16" creationId="{A500644E-C1D8-45DB-E360-8845858FFC4F}"/>
+          </ac:picMkLst>
+        </pc:picChg>
       </pc:sldChg>
       <pc:sldMasterChg chg="modSp mod">
         <pc:chgData name="David O'Hara" userId="8f90669b-8651-42ab-8d95-20602fbdf8e8" providerId="ADAL" clId="{A236AE32-B983-55C9-B7CE-2378BA1C83AB}" dt="2026-07-20T21:00:18.911" v="54" actId="20577"/>
@@ -549,7 +597,7 @@
           <a:p>
             <a:fld id="{FA586793-C8A1-F947-908B-E0EDCF860903}" type="datetimeFigureOut">
               <a:rPr lang="en-US" smtClean="0"/>
-              <a:t>7/20/26</a:t>
+              <a:t>7/22/26</a:t>
             </a:fld>
             <a:endParaRPr lang="en-US"/>
           </a:p>
@@ -726,7 +774,7 @@
           <a:p>
             <a:fld id="{E1A18E33-7982-7242-B011-19D9B39AC4BA}" type="datetimeFigureOut">
               <a:rPr lang="en-MX" smtClean="0"/>
-              <a:t>7/20/26</a:t>
+              <a:t>7/22/26</a:t>
             </a:fld>
             <a:endParaRPr lang="en-MX"/>
           </a:p>
@@ -1354,7 +1402,7 @@
           <a:p>
             <a:fld id="{3BDEB2A5-DDCF-604F-A595-5664085F7F7D}" type="slidenum">
               <a:rPr lang="en-MX" smtClean="0"/>
-              <a:t>5</a:t>
+              <a:t>6</a:t>
             </a:fld>
             <a:endParaRPr lang="en-MX"/>
           </a:p>
@@ -1438,7 +1486,7 @@
           <a:p>
             <a:fld id="{3BDEB2A5-DDCF-604F-A595-5664085F7F7D}" type="slidenum">
               <a:rPr lang="en-MX" smtClean="0"/>
-              <a:t>6</a:t>
+              <a:t>7</a:t>
             </a:fld>
             <a:endParaRPr lang="en-MX"/>
           </a:p>
@@ -2532,7 +2580,7 @@
           <a:p>
             <a:fld id="{AC5F636A-0D47-464A-B2A3-36F3F5FA6DF8}" type="datetimeFigureOut">
               <a:rPr lang="en-US" smtClean="0"/>
-              <a:t>7/20/26</a:t>
+              <a:t>7/22/26</a:t>
             </a:fld>
             <a:endParaRPr lang="en-US"/>
           </a:p>
@@ -7360,6 +7408,494 @@
   <p:cSld>
     <p:spTree>
       <p:nvGrpSpPr>
+        <p:cNvPr id="1" name=""/>
+        <p:cNvGrpSpPr/>
+        <p:nvPr/>
+      </p:nvGrpSpPr>
+      <p:grpSpPr>
+        <a:xfrm>
+          <a:off x="0" y="0"/>
+          <a:ext cx="0" cy="0"/>
+          <a:chOff x="0" y="0"/>
+          <a:chExt cx="0" cy="0"/>
+        </a:xfrm>
+      </p:grpSpPr>
+      <p:sp>
+        <p:nvSpPr>
+          <p:cNvPr id="17" name="Title 16"/>
+          <p:cNvSpPr>
+            <a:spLocks noGrp="1"/>
+          </p:cNvSpPr>
+          <p:nvPr>
+            <p:ph type="title"/>
+          </p:nvPr>
+        </p:nvSpPr>
+        <p:spPr/>
+        <p:txBody>
+          <a:bodyPr>
+            <a:normAutofit/>
+          </a:bodyPr>
+          <a:lstStyle/>
+          <a:p>
+            <a:r>
+              <a:rPr lang="en-US" dirty="0">
+                <a:latin typeface="+mn-lt"/>
+              </a:rPr>
+              <a:t>The Vision: One Brand, Every Day of the Year</a:t>
+            </a:r>
+          </a:p>
+        </p:txBody>
+      </p:sp>
+      <p:sp>
+        <p:nvSpPr>
+          <p:cNvPr id="5" name="TextBox 4"/>
+          <p:cNvSpPr txBox="1"/>
+          <p:nvPr/>
+        </p:nvSpPr>
+        <p:spPr>
+          <a:xfrm>
+            <a:off x="503950" y="1386821"/>
+            <a:ext cx="4067106" cy="4031873"/>
+          </a:xfrm>
+          <a:prstGeom prst="rect">
+            <a:avLst/>
+          </a:prstGeom>
+          <a:noFill/>
+        </p:spPr>
+        <p:txBody>
+          <a:bodyPr wrap="square" numCol="1" rtlCol="0">
+            <a:spAutoFit/>
+          </a:bodyPr>
+          <a:lstStyle/>
+          <a:p>
+            <a:r>
+              <a:rPr lang="en-US" sz="1600" b="1" dirty="0">
+                <a:solidFill>
+                  <a:srgbClr val="168FB2"/>
+                </a:solidFill>
+                <a:cs typeface="Poppins" pitchFamily="2" charset="77"/>
+              </a:rPr>
+              <a:t>Delight Shouldn’t Have a Season</a:t>
+            </a:r>
+          </a:p>
+          <a:p>
+            <a:endParaRPr lang="en-US" sz="1600" b="1" dirty="0">
+              <a:solidFill>
+                <a:srgbClr val="168FB2"/>
+              </a:solidFill>
+              <a:cs typeface="Poppins" pitchFamily="2" charset="77"/>
+            </a:endParaRPr>
+          </a:p>
+          <a:p>
+            <a:r>
+              <a:rPr lang="en-US" sz="1400" dirty="0">
+                <a:solidFill>
+                  <a:schemeClr val="tx1">
+                    <a:lumMod val="75000"/>
+                    <a:lumOff val="25000"/>
+                  </a:schemeClr>
+                </a:solidFill>
+                <a:cs typeface="Poppins" pitchFamily="2" charset="77"/>
+              </a:rPr>
+              <a:t>Santa’s Wonderland has built something rare every December: an experience that creates genuine delight. The platform vision carries that same feeling of delight and recognition across every month of the year, not just the holiday season.</a:t>
+            </a:r>
+          </a:p>
+          <a:p>
+            <a:endParaRPr lang="en-US" sz="1400" dirty="0">
+              <a:solidFill>
+                <a:schemeClr val="tx1">
+                  <a:lumMod val="75000"/>
+                  <a:lumOff val="25000"/>
+                </a:schemeClr>
+              </a:solidFill>
+              <a:cs typeface="Poppins" pitchFamily="2" charset="77"/>
+            </a:endParaRPr>
+          </a:p>
+          <a:p>
+            <a:r>
+              <a:rPr lang="en-US" sz="1400" dirty="0">
+                <a:solidFill>
+                  <a:schemeClr val="tx1">
+                    <a:lumMod val="75000"/>
+                    <a:lumOff val="25000"/>
+                  </a:schemeClr>
+                </a:solidFill>
+                <a:cs typeface="Poppins" pitchFamily="2" charset="77"/>
+              </a:rPr>
+              <a:t>Ticketing, the mobile app, on-site operations, guest service, and marketing all draw from one guest identity. A family that visits over the holidays and returns for a spring event should feel like the same brand remembers them, not like they’re introducing themselves to a stranger.</a:t>
+            </a:r>
+          </a:p>
+          <a:p>
+            <a:endParaRPr lang="en-US" sz="1400" dirty="0">
+              <a:solidFill>
+                <a:schemeClr val="tx1">
+                  <a:lumMod val="75000"/>
+                  <a:lumOff val="25000"/>
+                </a:schemeClr>
+              </a:solidFill>
+              <a:cs typeface="Poppins" pitchFamily="2" charset="77"/>
+            </a:endParaRPr>
+          </a:p>
+          <a:p>
+            <a:r>
+              <a:rPr lang="en-US" sz="1400" dirty="0">
+                <a:solidFill>
+                  <a:schemeClr val="tx1">
+                    <a:lumMod val="75000"/>
+                    <a:lumOff val="25000"/>
+                  </a:schemeClr>
+                </a:solidFill>
+                <a:cs typeface="Poppins" pitchFamily="2" charset="77"/>
+              </a:rPr>
+              <a:t>That consistency is what turns a seasonal attraction into a brand guests live inside all year long and for years to come.</a:t>
+            </a:r>
+            <a:endParaRPr lang="en-US" sz="1200" dirty="0">
+              <a:solidFill>
+                <a:schemeClr val="tx1">
+                  <a:lumMod val="75000"/>
+                  <a:lumOff val="25000"/>
+                </a:schemeClr>
+              </a:solidFill>
+              <a:cs typeface="Poppins" pitchFamily="2" charset="77"/>
+            </a:endParaRPr>
+          </a:p>
+        </p:txBody>
+      </p:sp>
+      <p:cxnSp>
+        <p:nvCxnSpPr>
+          <p:cNvPr id="10" name="Straight Connector 9"/>
+          <p:cNvCxnSpPr>
+            <a:cxnSpLocks/>
+          </p:cNvCxnSpPr>
+          <p:nvPr/>
+        </p:nvCxnSpPr>
+        <p:spPr>
+          <a:xfrm>
+            <a:off x="4744994" y="1318252"/>
+            <a:ext cx="0" cy="4927021"/>
+          </a:xfrm>
+          <a:prstGeom prst="line">
+            <a:avLst/>
+          </a:prstGeom>
+          <a:ln>
+            <a:solidFill>
+              <a:schemeClr val="tx1"/>
+            </a:solidFill>
+          </a:ln>
+        </p:spPr>
+        <p:style>
+          <a:lnRef idx="1">
+            <a:schemeClr val="accent1"/>
+          </a:lnRef>
+          <a:fillRef idx="0">
+            <a:schemeClr val="accent1"/>
+          </a:fillRef>
+          <a:effectRef idx="0">
+            <a:schemeClr val="accent1"/>
+          </a:effectRef>
+          <a:fontRef idx="minor">
+            <a:schemeClr val="tx1"/>
+          </a:fontRef>
+        </p:style>
+      </p:cxnSp>
+      <p:sp>
+        <p:nvSpPr>
+          <p:cNvPr id="2" name="TextBox 1"/>
+          <p:cNvSpPr txBox="1"/>
+          <p:nvPr/>
+        </p:nvSpPr>
+        <p:spPr>
+          <a:xfrm>
+            <a:off x="4930753" y="1368578"/>
+            <a:ext cx="3660084" cy="338554"/>
+          </a:xfrm>
+          <a:prstGeom prst="rect">
+            <a:avLst/>
+          </a:prstGeom>
+          <a:noFill/>
+        </p:spPr>
+        <p:txBody>
+          <a:bodyPr wrap="square">
+            <a:spAutoFit/>
+          </a:bodyPr>
+          <a:lstStyle/>
+          <a:p>
+            <a:r>
+              <a:rPr lang="en-US" sz="1600" b="1" dirty="0">
+                <a:solidFill>
+                  <a:srgbClr val="168FB2"/>
+                </a:solidFill>
+                <a:cs typeface="Poppins" pitchFamily="2" charset="77"/>
+              </a:rPr>
+              <a:t>What the Unified Platform Makes Possible</a:t>
+            </a:r>
+          </a:p>
+        </p:txBody>
+      </p:sp>
+      <p:sp>
+        <p:nvSpPr>
+          <p:cNvPr id="3" name="TextBox 2"/>
+          <p:cNvSpPr txBox="1"/>
+          <p:nvPr/>
+        </p:nvSpPr>
+        <p:spPr>
+          <a:xfrm>
+            <a:off x="6118425" y="1929885"/>
+            <a:ext cx="5869360" cy="923330"/>
+          </a:xfrm>
+          <a:prstGeom prst="rect">
+            <a:avLst/>
+          </a:prstGeom>
+          <a:noFill/>
+        </p:spPr>
+        <p:txBody>
+          <a:bodyPr wrap="square">
+            <a:spAutoFit/>
+          </a:bodyPr>
+          <a:lstStyle/>
+          <a:p>
+            <a:r>
+              <a:rPr lang="en-US" sz="1800" b="1" dirty="0">
+                <a:solidFill>
+                  <a:srgbClr val="FFC000"/>
+                </a:solidFill>
+                <a:cs typeface="Poppins" pitchFamily="2" charset="77"/>
+              </a:rPr>
+              <a:t>Consistent Experience, Every Channel</a:t>
+            </a:r>
+          </a:p>
+          <a:p>
+            <a:r>
+              <a:rPr lang="en-US" sz="1200" i="1" dirty="0">
+                <a:solidFill>
+                  <a:schemeClr val="bg2">
+                    <a:lumMod val="25000"/>
+                  </a:schemeClr>
+                </a:solidFill>
+                <a:cs typeface="Poppins" pitchFamily="2" charset="77"/>
+              </a:rPr>
+              <a:t>Ticketing, app, on-site operations, and guest service all speak from the same guest profile, so the experience feels seamless whether a guest is buying tickets in July or walking through the gates in December.</a:t>
+            </a:r>
+          </a:p>
+        </p:txBody>
+      </p:sp>
+      <p:sp>
+        <p:nvSpPr>
+          <p:cNvPr id="6" name="TextBox 5"/>
+          <p:cNvSpPr txBox="1"/>
+          <p:nvPr/>
+        </p:nvSpPr>
+        <p:spPr>
+          <a:xfrm>
+            <a:off x="6107911" y="3480936"/>
+            <a:ext cx="5682076" cy="923330"/>
+          </a:xfrm>
+          <a:prstGeom prst="rect">
+            <a:avLst/>
+          </a:prstGeom>
+          <a:noFill/>
+        </p:spPr>
+        <p:txBody>
+          <a:bodyPr wrap="square">
+            <a:spAutoFit/>
+          </a:bodyPr>
+          <a:lstStyle/>
+          <a:p>
+            <a:r>
+              <a:rPr lang="en-US" sz="1800" b="1" dirty="0">
+                <a:solidFill>
+                  <a:srgbClr val="FFC000"/>
+                </a:solidFill>
+                <a:cs typeface="Poppins" pitchFamily="2" charset="77"/>
+              </a:rPr>
+              <a:t>Loyalty That Compounds, Year After Year</a:t>
+            </a:r>
+          </a:p>
+          <a:p>
+            <a:r>
+              <a:rPr lang="en-US" sz="1200" i="1" dirty="0">
+                <a:solidFill>
+                  <a:schemeClr val="bg2">
+                    <a:lumMod val="25000"/>
+                  </a:schemeClr>
+                </a:solidFill>
+                <a:cs typeface="Poppins" pitchFamily="2" charset="77"/>
+              </a:rPr>
+              <a:t>A unified guest record lets Santa’s Wonderland recognize returning guests and reward tenure, turning a one-time visitor into a multi-year relationship instead of restarting from zero every season.</a:t>
+            </a:r>
+          </a:p>
+        </p:txBody>
+      </p:sp>
+      <p:sp>
+        <p:nvSpPr>
+          <p:cNvPr id="7" name="TextBox 6"/>
+          <p:cNvSpPr txBox="1"/>
+          <p:nvPr/>
+        </p:nvSpPr>
+        <p:spPr>
+          <a:xfrm>
+            <a:off x="6118421" y="5031936"/>
+            <a:ext cx="5671566" cy="923330"/>
+          </a:xfrm>
+          <a:prstGeom prst="rect">
+            <a:avLst/>
+          </a:prstGeom>
+          <a:noFill/>
+        </p:spPr>
+        <p:txBody>
+          <a:bodyPr wrap="square">
+            <a:spAutoFit/>
+          </a:bodyPr>
+          <a:lstStyle/>
+          <a:p>
+            <a:r>
+              <a:rPr lang="en-US" sz="1800" b="1" dirty="0">
+                <a:solidFill>
+                  <a:srgbClr val="FFC000"/>
+                </a:solidFill>
+                <a:cs typeface="Poppins" pitchFamily="2" charset="77"/>
+              </a:rPr>
+              <a:t>Reasons to Stay Engaged Between Visits</a:t>
+            </a:r>
+          </a:p>
+          <a:p>
+            <a:r>
+              <a:rPr lang="en-US" sz="1200" i="1" dirty="0">
+                <a:solidFill>
+                  <a:schemeClr val="bg2">
+                    <a:lumMod val="25000"/>
+                  </a:schemeClr>
+                </a:solidFill>
+                <a:cs typeface="Poppins" pitchFamily="2" charset="77"/>
+              </a:rPr>
+              <a:t>Off-season previews, membership perks, and personalized offers give guests a reason to stay connected to the brand year-round, not just during the holiday rush.</a:t>
+            </a:r>
+          </a:p>
+        </p:txBody>
+      </p:sp>
+      <p:pic>
+        <p:nvPicPr>
+          <p:cNvPr id="8" name="Graphic 7" descr="Network outline">
+            <a:extLst>
+              <a:ext uri="{FF2B5EF4-FFF2-40B4-BE49-F238E27FC236}">
+                <a16:creationId xmlns:a16="http://schemas.microsoft.com/office/drawing/2014/main" id="{B06CB167-3161-DB07-9101-A592AF12E514}"/>
+              </a:ext>
+            </a:extLst>
+          </p:cNvPr>
+          <p:cNvPicPr>
+            <a:picLocks noChangeAspect="1"/>
+          </p:cNvPicPr>
+          <p:nvPr/>
+        </p:nvPicPr>
+        <p:blipFill>
+          <a:blip>
+            <a:extLst>
+              <a:ext uri="{96DAC541-7B7A-43D3-8B79-37D633B846F1}">
+                <asvg:svgBlip xmlns:asvg="http://schemas.microsoft.com/office/drawing/2016/SVG/main" r:embed="rId2"/>
+              </a:ext>
+            </a:extLst>
+          </a:blip>
+          <a:srcRect/>
+          <a:stretch/>
+        </p:blipFill>
+        <p:spPr>
+          <a:xfrm>
+            <a:off x="4969253" y="1973456"/>
+            <a:ext cx="914400" cy="914400"/>
+          </a:xfrm>
+          <a:prstGeom prst="rect">
+            <a:avLst/>
+          </a:prstGeom>
+        </p:spPr>
+      </p:pic>
+      <p:pic>
+        <p:nvPicPr>
+          <p:cNvPr id="9" name="Graphic 8" descr="Ticket outline">
+            <a:extLst>
+              <a:ext uri="{FF2B5EF4-FFF2-40B4-BE49-F238E27FC236}">
+                <a16:creationId xmlns:a16="http://schemas.microsoft.com/office/drawing/2014/main" id="{261FB8CE-0914-DBF3-D9C4-7419A6A66A79}"/>
+              </a:ext>
+            </a:extLst>
+          </p:cNvPr>
+          <p:cNvPicPr>
+            <a:picLocks noChangeAspect="1"/>
+          </p:cNvPicPr>
+          <p:nvPr/>
+        </p:nvPicPr>
+        <p:blipFill>
+          <a:blip>
+            <a:extLst>
+              <a:ext uri="{96DAC541-7B7A-43D3-8B79-37D633B846F1}">
+                <asvg:svgBlip xmlns:asvg="http://schemas.microsoft.com/office/drawing/2016/SVG/main" r:embed="rId3"/>
+              </a:ext>
+            </a:extLst>
+          </a:blip>
+          <a:srcRect/>
+          <a:stretch/>
+        </p:blipFill>
+        <p:spPr>
+          <a:xfrm>
+            <a:off x="4969253" y="3410370"/>
+            <a:ext cx="914400" cy="914400"/>
+          </a:xfrm>
+          <a:prstGeom prst="rect">
+            <a:avLst/>
+          </a:prstGeom>
+        </p:spPr>
+      </p:pic>
+      <p:pic>
+        <p:nvPicPr>
+          <p:cNvPr id="16" name="Graphic 15" descr="Family with boy outline">
+            <a:extLst>
+              <a:ext uri="{FF2B5EF4-FFF2-40B4-BE49-F238E27FC236}">
+                <a16:creationId xmlns:a16="http://schemas.microsoft.com/office/drawing/2014/main" id="{A500644E-C1D8-45DB-E360-8845858FFC4F}"/>
+              </a:ext>
+            </a:extLst>
+          </p:cNvPr>
+          <p:cNvPicPr>
+            <a:picLocks noChangeAspect="1"/>
+          </p:cNvPicPr>
+          <p:nvPr/>
+        </p:nvPicPr>
+        <p:blipFill>
+          <a:blip>
+            <a:extLst>
+              <a:ext uri="{96DAC541-7B7A-43D3-8B79-37D633B846F1}">
+                <asvg:svgBlip xmlns:asvg="http://schemas.microsoft.com/office/drawing/2016/SVG/main" r:embed="rId4"/>
+              </a:ext>
+            </a:extLst>
+          </a:blip>
+          <a:srcRect/>
+          <a:stretch/>
+        </p:blipFill>
+        <p:spPr>
+          <a:xfrm>
+            <a:off x="4969253" y="4876100"/>
+            <a:ext cx="914400" cy="914400"/>
+          </a:xfrm>
+          <a:prstGeom prst="rect">
+            <a:avLst/>
+          </a:prstGeom>
+        </p:spPr>
+      </p:pic>
+    </p:spTree>
+    <p:extLst>
+      <p:ext uri="{BB962C8B-B14F-4D97-AF65-F5344CB8AC3E}">
+        <p14:creationId xmlns:p14="http://schemas.microsoft.com/office/powerpoint/2010/main" val="2650764471"/>
+      </p:ext>
+    </p:extLst>
+  </p:cSld>
+  <p:clrMapOvr>
+    <a:masterClrMapping/>
+  </p:clrMapOvr>
+</p:sld>
+</file>
+
+<file path=ppt/slides/slide4.xml><?xml version="1.0" encoding="utf-8"?>
+<p:sld xmlns:a="http://schemas.openxmlformats.org/drawingml/2006/main" xmlns:r="http://schemas.openxmlformats.org/officeDocument/2006/relationships" xmlns:p="http://schemas.openxmlformats.org/presentationml/2006/main">
+  <p:cSld>
+    <p:spTree>
+      <p:nvGrpSpPr>
         <p:cNvPr id="1" name="Shape 318"/>
         <p:cNvGrpSpPr/>
         <p:nvPr/>
@@ -8698,100 +9234,6 @@
 </p:sld>
 </file>
 
-<file path=ppt/slides/slide4.xml><?xml version="1.0" encoding="utf-8"?>
-<p:sld xmlns:a="http://schemas.openxmlformats.org/drawingml/2006/main" xmlns:r="http://schemas.openxmlformats.org/officeDocument/2006/relationships" xmlns:p="http://schemas.openxmlformats.org/presentationml/2006/main">
-  <p:cSld>
-    <p:spTree>
-      <p:nvGrpSpPr>
-        <p:cNvPr id="1" name=""/>
-        <p:cNvGrpSpPr/>
-        <p:nvPr/>
-      </p:nvGrpSpPr>
-      <p:grpSpPr>
-        <a:xfrm>
-          <a:off x="0" y="0"/>
-          <a:ext cx="0" cy="0"/>
-          <a:chOff x="0" y="0"/>
-          <a:chExt cx="0" cy="0"/>
-        </a:xfrm>
-      </p:grpSpPr>
-      <p:sp>
-        <p:nvSpPr>
-          <p:cNvPr id="2" name="Title 1">
-            <a:extLst>
-              <a:ext uri="{FF2B5EF4-FFF2-40B4-BE49-F238E27FC236}">
-                <a16:creationId xmlns:a16="http://schemas.microsoft.com/office/drawing/2014/main" id="{AA275871-7AEF-131B-F4E6-26F4F7861B89}"/>
-              </a:ext>
-            </a:extLst>
-          </p:cNvPr>
-          <p:cNvSpPr>
-            <a:spLocks noGrp="1"/>
-          </p:cNvSpPr>
-          <p:nvPr>
-            <p:ph type="title"/>
-          </p:nvPr>
-        </p:nvSpPr>
-        <p:spPr>
-          <a:xfrm>
-            <a:off x="705913" y="2933878"/>
-            <a:ext cx="10515600" cy="508001"/>
-          </a:xfrm>
-        </p:spPr>
-        <p:txBody>
-          <a:bodyPr>
-            <a:normAutofit fontScale="90000"/>
-          </a:bodyPr>
-          <a:lstStyle/>
-          <a:p>
-            <a:r>
-              <a:rPr lang="en-US" dirty="0"/>
-              <a:t>Recommended Approach</a:t>
-            </a:r>
-            <a:br>
-              <a:rPr lang="en-US" dirty="0"/>
-            </a:br>
-            <a:endParaRPr lang="en-US" dirty="0"/>
-          </a:p>
-        </p:txBody>
-      </p:sp>
-      <p:sp>
-        <p:nvSpPr>
-          <p:cNvPr id="5" name="Subtitle 4">
-            <a:extLst>
-              <a:ext uri="{FF2B5EF4-FFF2-40B4-BE49-F238E27FC236}">
-                <a16:creationId xmlns:a16="http://schemas.microsoft.com/office/drawing/2014/main" id="{A6F87D52-FD94-FDC8-26E2-7A32D19DDFFD}"/>
-              </a:ext>
-            </a:extLst>
-          </p:cNvPr>
-          <p:cNvSpPr>
-            <a:spLocks noGrp="1"/>
-          </p:cNvSpPr>
-          <p:nvPr>
-            <p:ph type="subTitle" idx="1"/>
-          </p:nvPr>
-        </p:nvSpPr>
-        <p:spPr/>
-        <p:txBody>
-          <a:bodyPr/>
-          <a:lstStyle/>
-          <a:p>
-            <a:endParaRPr lang="en-US"/>
-          </a:p>
-        </p:txBody>
-      </p:sp>
-    </p:spTree>
-    <p:extLst>
-      <p:ext uri="{BB962C8B-B14F-4D97-AF65-F5344CB8AC3E}">
-        <p14:creationId xmlns:p14="http://schemas.microsoft.com/office/powerpoint/2010/main" val="1451867943"/>
-      </p:ext>
-    </p:extLst>
-  </p:cSld>
-  <p:clrMapOvr>
-    <a:masterClrMapping/>
-  </p:clrMapOvr>
-</p:sld>
-</file>
-
 <file path=ppt/slides/slide5.xml><?xml version="1.0" encoding="utf-8"?>
 <p:sld xmlns:a="http://schemas.openxmlformats.org/drawingml/2006/main" xmlns:r="http://schemas.openxmlformats.org/officeDocument/2006/relationships" xmlns:p="http://schemas.openxmlformats.org/presentationml/2006/main">
   <p:cSld>
@@ -8814,7 +9256,7 @@
           <p:cNvPr id="2" name="Title 1">
             <a:extLst>
               <a:ext uri="{FF2B5EF4-FFF2-40B4-BE49-F238E27FC236}">
-                <a16:creationId xmlns:a16="http://schemas.microsoft.com/office/drawing/2014/main" id="{A6BF37F2-5E51-EBE6-FB74-03ECD1F0CB05}"/>
+                <a16:creationId xmlns:a16="http://schemas.microsoft.com/office/drawing/2014/main" id="{AA275871-7AEF-131B-F4E6-26F4F7861B89}"/>
               </a:ext>
             </a:extLst>
           </p:cNvPr>
@@ -8827,38 +9269,33 @@
         </p:nvSpPr>
         <p:spPr>
           <a:xfrm>
-            <a:off x="468489" y="434446"/>
-            <a:ext cx="11205668" cy="667808"/>
+            <a:off x="705913" y="2933878"/>
+            <a:ext cx="10515600" cy="508001"/>
           </a:xfrm>
         </p:spPr>
         <p:txBody>
-          <a:bodyPr anchor="b">
-            <a:normAutofit/>
+          <a:bodyPr>
+            <a:normAutofit fontScale="90000"/>
           </a:bodyPr>
-          <a:lstStyle>
-            <a:lvl1pPr>
-              <a:defRPr sz="3200" b="1">
-                <a:solidFill>
-                  <a:srgbClr val="005596"/>
-                </a:solidFill>
-                <a:latin typeface="Poppins" pitchFamily="2" charset="77"/>
-                <a:cs typeface="Poppins" pitchFamily="2" charset="77"/>
-              </a:defRPr>
-            </a:lvl1pPr>
-          </a:lstStyle>
-          <a:p>
-            <a:r>
-              <a:t>Discovery &amp; Assessment: What It Delivers</a:t>
-            </a:r>
+          <a:lstStyle/>
+          <a:p>
+            <a:r>
+              <a:rPr lang="en-US" dirty="0"/>
+              <a:t>Recommended Approach</a:t>
+            </a:r>
+            <a:br>
+              <a:rPr lang="en-US" dirty="0"/>
+            </a:br>
+            <a:endParaRPr lang="en-US" dirty="0"/>
           </a:p>
         </p:txBody>
       </p:sp>
       <p:sp>
         <p:nvSpPr>
-          <p:cNvPr id="7" name="Text Placeholder 6">
-            <a:extLst>
-              <a:ext uri="{FF2B5EF4-FFF2-40B4-BE49-F238E27FC236}">
-                <a16:creationId xmlns:a16="http://schemas.microsoft.com/office/drawing/2014/main" id="{8B772F0C-A603-1AAE-F130-CB75D94E66CB}"/>
+          <p:cNvPr id="5" name="Subtitle 4">
+            <a:extLst>
+              <a:ext uri="{FF2B5EF4-FFF2-40B4-BE49-F238E27FC236}">
+                <a16:creationId xmlns:a16="http://schemas.microsoft.com/office/drawing/2014/main" id="{A6F87D52-FD94-FDC8-26E2-7A32D19DDFFD}"/>
               </a:ext>
             </a:extLst>
           </p:cNvPr>
@@ -8866,159 +9303,28 @@
             <a:spLocks noGrp="1"/>
           </p:cNvSpPr>
           <p:nvPr>
-            <p:ph type="body" sz="quarter" idx="11" hasCustomPrompt="1"/>
+            <p:ph type="subTitle" idx="1"/>
           </p:nvPr>
         </p:nvSpPr>
-        <p:spPr>
-          <a:xfrm>
-            <a:off x="468313" y="1030638"/>
-            <a:ext cx="11206162" cy="667809"/>
-          </a:xfrm>
-        </p:spPr>
+        <p:spPr/>
         <p:txBody>
-          <a:bodyPr lIns="72000" tIns="36000" rIns="216000" bIns="288000">
-            <a:normAutofit/>
-          </a:bodyPr>
-          <a:lstStyle>
-            <a:lvl1pPr>
-              <a:lnSpc>
-                <a:spcPct val="100000"/>
-              </a:lnSpc>
-              <a:spcBef>
-                <a:spcPts val="8"/>
-              </a:spcBef>
-              <a:spcAft>
-                <a:spcPts val="8"/>
-              </a:spcAft>
-              <a:defRPr sz="2000" b="0" i="0">
-                <a:solidFill>
-                  <a:schemeClr val="bg1">
-                    <a:lumMod val="50000"/>
-                  </a:schemeClr>
-                </a:solidFill>
-                <a:latin typeface="Poppins Medium" pitchFamily="2" charset="77"/>
-                <a:cs typeface="Poppins Medium" pitchFamily="2" charset="77"/>
-              </a:defRPr>
-            </a:lvl1pPr>
-          </a:lstStyle>
-          <a:p>
-            <a:r>
-              <a:rPr dirty="0"/>
-              <a:t>A 6-week</a:t>
-            </a:r>
-            <a:r>
-              <a:rPr lang="en-US" dirty="0"/>
-              <a:t> </a:t>
-            </a:r>
-            <a:r>
-              <a:rPr dirty="0"/>
-              <a:t>engagement to map the full platform vision</a:t>
-            </a:r>
+          <a:bodyPr/>
+          <a:lstStyle/>
+          <a:p>
+            <a:endParaRPr lang="en-US"/>
           </a:p>
         </p:txBody>
       </p:sp>
-      <p:sp>
-        <p:nvSpPr>
-          <p:cNvPr id="10" name="Content Placeholder 9">
-            <a:extLst>
-              <a:ext uri="{FF2B5EF4-FFF2-40B4-BE49-F238E27FC236}">
-                <a16:creationId xmlns:a16="http://schemas.microsoft.com/office/drawing/2014/main" id="{76DB217A-F6B3-74AC-D9F2-0EF851F4881D}"/>
-              </a:ext>
-            </a:extLst>
-          </p:cNvPr>
-          <p:cNvSpPr>
-            <a:spLocks noGrp="1"/>
-          </p:cNvSpPr>
-          <p:nvPr>
-            <p:ph sz="quarter" idx="10"/>
-          </p:nvPr>
-        </p:nvSpPr>
-        <p:spPr>
-          <a:xfrm>
-            <a:off x="468313" y="1885244"/>
-            <a:ext cx="11206162" cy="3999619"/>
-          </a:xfrm>
-          <a:prstGeom prst="rect">
-            <a:avLst/>
-          </a:prstGeom>
-        </p:spPr>
-        <p:txBody>
-          <a:bodyPr>
-            <a:normAutofit/>
-          </a:bodyPr>
-          <a:lstStyle>
-            <a:lvl1pPr>
-              <a:defRPr sz="1400">
-                <a:latin typeface="Khula" panose="02000000000000000000" pitchFamily="2" charset="0"/>
-                <a:cs typeface="Khula" panose="02000000000000000000" pitchFamily="2" charset="0"/>
-              </a:defRPr>
-            </a:lvl1pPr>
-          </a:lstStyle>
-          <a:p>
-            <a:r>
-              <a:rPr sz="2000" b="1" dirty="0"/>
-              <a:t>Activities</a:t>
-            </a:r>
-          </a:p>
-          <a:p>
-            <a:pPr lvl="1"/>
-            <a:r>
-              <a:rPr sz="1600" b="0" dirty="0"/>
-              <a:t>Review current-state systems: ticketing platform, HubSpot CRM, Zendesk, Square, and the LMS/payroll tools in scope</a:t>
-            </a:r>
-          </a:p>
-          <a:p>
-            <a:pPr lvl="1"/>
-            <a:r>
-              <a:rPr sz="1600" b="0" dirty="0"/>
-              <a:t>Stakeholder workshops with Leadership and Operations to map the full guest and employee experience</a:t>
-            </a:r>
-          </a:p>
-          <a:p>
-            <a:pPr lvl="1"/>
-            <a:r>
-              <a:rPr sz="1600" b="0" dirty="0"/>
-              <a:t>Map the complete platform vision: ticketing, loyalty, guest data, employee portal, LMS, payroll, mobile ordering</a:t>
-            </a:r>
-          </a:p>
-          <a:p>
-            <a:endParaRPr lang="en-US" sz="2000" b="1" dirty="0"/>
-          </a:p>
-          <a:p>
-            <a:r>
-              <a:rPr sz="2000" b="1" dirty="0"/>
-              <a:t>Deliverables</a:t>
-            </a:r>
-          </a:p>
-          <a:p>
-            <a:pPr lvl="1"/>
-            <a:r>
-              <a:rPr sz="1600" b="0" dirty="0"/>
-              <a:t>A recommended technology architecture and cloud strategy</a:t>
-            </a:r>
-          </a:p>
-          <a:p>
-            <a:pPr lvl="1"/>
-            <a:r>
-              <a:rPr sz="1600" b="0" dirty="0"/>
-              <a:t>A phased platform roadmap so Phase 1 doesn't box in what comes next</a:t>
-            </a:r>
-          </a:p>
-          <a:p>
-            <a:pPr lvl="1"/>
-            <a:r>
-              <a:rPr sz="1600" b="0" dirty="0"/>
-              <a:t>A detailed cost, timeline, and acceptance-criteria estimate for Phase 1 (Ticketing + Loyalty)</a:t>
-            </a:r>
-          </a:p>
-        </p:txBody>
-      </p:sp>
     </p:spTree>
+    <p:extLst>
+      <p:ext uri="{BB962C8B-B14F-4D97-AF65-F5344CB8AC3E}">
+        <p14:creationId xmlns:p14="http://schemas.microsoft.com/office/powerpoint/2010/main" val="1451867943"/>
+      </p:ext>
+    </p:extLst>
   </p:cSld>
   <p:clrMapOvr>
     <a:masterClrMapping/>
   </p:clrMapOvr>
-  <p:transition spd="med"/>
 </p:sld>
 </file>
 
@@ -9078,6 +9384,236 @@
           </a:lstStyle>
           <a:p>
             <a:r>
+              <a:t>Discovery &amp; Assessment: What It Delivers</a:t>
+            </a:r>
+          </a:p>
+        </p:txBody>
+      </p:sp>
+      <p:sp>
+        <p:nvSpPr>
+          <p:cNvPr id="7" name="Text Placeholder 6">
+            <a:extLst>
+              <a:ext uri="{FF2B5EF4-FFF2-40B4-BE49-F238E27FC236}">
+                <a16:creationId xmlns:a16="http://schemas.microsoft.com/office/drawing/2014/main" id="{8B772F0C-A603-1AAE-F130-CB75D94E66CB}"/>
+              </a:ext>
+            </a:extLst>
+          </p:cNvPr>
+          <p:cNvSpPr>
+            <a:spLocks noGrp="1"/>
+          </p:cNvSpPr>
+          <p:nvPr>
+            <p:ph type="body" sz="quarter" idx="11" hasCustomPrompt="1"/>
+          </p:nvPr>
+        </p:nvSpPr>
+        <p:spPr>
+          <a:xfrm>
+            <a:off x="468313" y="1030638"/>
+            <a:ext cx="11206162" cy="667809"/>
+          </a:xfrm>
+        </p:spPr>
+        <p:txBody>
+          <a:bodyPr lIns="72000" tIns="36000" rIns="216000" bIns="288000">
+            <a:normAutofit/>
+          </a:bodyPr>
+          <a:lstStyle>
+            <a:lvl1pPr>
+              <a:lnSpc>
+                <a:spcPct val="100000"/>
+              </a:lnSpc>
+              <a:spcBef>
+                <a:spcPts val="8"/>
+              </a:spcBef>
+              <a:spcAft>
+                <a:spcPts val="8"/>
+              </a:spcAft>
+              <a:defRPr sz="2000" b="0" i="0">
+                <a:solidFill>
+                  <a:schemeClr val="bg1">
+                    <a:lumMod val="50000"/>
+                  </a:schemeClr>
+                </a:solidFill>
+                <a:latin typeface="Poppins Medium" pitchFamily="2" charset="77"/>
+                <a:cs typeface="Poppins Medium" pitchFamily="2" charset="77"/>
+              </a:defRPr>
+            </a:lvl1pPr>
+          </a:lstStyle>
+          <a:p>
+            <a:r>
+              <a:rPr dirty="0"/>
+              <a:t>A 6-week</a:t>
+            </a:r>
+            <a:r>
+              <a:rPr lang="en-US" dirty="0"/>
+              <a:t> </a:t>
+            </a:r>
+            <a:r>
+              <a:rPr dirty="0"/>
+              <a:t>engagement to map the full platform vision</a:t>
+            </a:r>
+          </a:p>
+        </p:txBody>
+      </p:sp>
+      <p:sp>
+        <p:nvSpPr>
+          <p:cNvPr id="10" name="Content Placeholder 9">
+            <a:extLst>
+              <a:ext uri="{FF2B5EF4-FFF2-40B4-BE49-F238E27FC236}">
+                <a16:creationId xmlns:a16="http://schemas.microsoft.com/office/drawing/2014/main" id="{76DB217A-F6B3-74AC-D9F2-0EF851F4881D}"/>
+              </a:ext>
+            </a:extLst>
+          </p:cNvPr>
+          <p:cNvSpPr>
+            <a:spLocks noGrp="1"/>
+          </p:cNvSpPr>
+          <p:nvPr>
+            <p:ph sz="quarter" idx="10"/>
+          </p:nvPr>
+        </p:nvSpPr>
+        <p:spPr>
+          <a:xfrm>
+            <a:off x="468313" y="1885244"/>
+            <a:ext cx="11206162" cy="3999619"/>
+          </a:xfrm>
+          <a:prstGeom prst="rect">
+            <a:avLst/>
+          </a:prstGeom>
+        </p:spPr>
+        <p:txBody>
+          <a:bodyPr>
+            <a:normAutofit/>
+          </a:bodyPr>
+          <a:lstStyle>
+            <a:lvl1pPr>
+              <a:defRPr sz="1400">
+                <a:latin typeface="Khula" panose="02000000000000000000" pitchFamily="2" charset="0"/>
+                <a:cs typeface="Khula" panose="02000000000000000000" pitchFamily="2" charset="0"/>
+              </a:defRPr>
+            </a:lvl1pPr>
+          </a:lstStyle>
+          <a:p>
+            <a:r>
+              <a:rPr sz="2000" b="1" dirty="0"/>
+              <a:t>Activities</a:t>
+            </a:r>
+          </a:p>
+          <a:p>
+            <a:pPr lvl="1"/>
+            <a:r>
+              <a:rPr sz="1600" b="0" dirty="0"/>
+              <a:t>Review current-state systems: ticketing platform, HubSpot CRM, Zendesk, Square, and the LMS/payroll tools in scope</a:t>
+            </a:r>
+          </a:p>
+          <a:p>
+            <a:pPr lvl="1"/>
+            <a:r>
+              <a:rPr sz="1600" b="0" dirty="0"/>
+              <a:t>Stakeholder workshops with Leadership and Operations to map the full guest and employee experience</a:t>
+            </a:r>
+          </a:p>
+          <a:p>
+            <a:pPr lvl="1"/>
+            <a:r>
+              <a:rPr sz="1600" b="0" dirty="0"/>
+              <a:t>Map the complete platform vision: ticketing, loyalty, guest data, employee portal, LMS, payroll, mobile ordering</a:t>
+            </a:r>
+          </a:p>
+          <a:p>
+            <a:endParaRPr lang="en-US" sz="2000" b="1" dirty="0"/>
+          </a:p>
+          <a:p>
+            <a:r>
+              <a:rPr sz="2000" b="1" dirty="0"/>
+              <a:t>Deliverables</a:t>
+            </a:r>
+          </a:p>
+          <a:p>
+            <a:pPr lvl="1"/>
+            <a:r>
+              <a:rPr sz="1600" b="0" dirty="0"/>
+              <a:t>A recommended technology architecture and cloud strategy</a:t>
+            </a:r>
+          </a:p>
+          <a:p>
+            <a:pPr lvl="1"/>
+            <a:r>
+              <a:rPr sz="1600" b="0" dirty="0"/>
+              <a:t>A phased platform roadmap so Phase 1 doesn't box in what comes next</a:t>
+            </a:r>
+          </a:p>
+          <a:p>
+            <a:pPr lvl="1"/>
+            <a:r>
+              <a:rPr sz="1600" b="0" dirty="0"/>
+              <a:t>A detailed cost, timeline, and acceptance-criteria estimate for Phase 1 (Ticketing + Loyalty)</a:t>
+            </a:r>
+          </a:p>
+        </p:txBody>
+      </p:sp>
+    </p:spTree>
+  </p:cSld>
+  <p:clrMapOvr>
+    <a:masterClrMapping/>
+  </p:clrMapOvr>
+  <p:transition spd="med"/>
+</p:sld>
+</file>
+
+<file path=ppt/slides/slide7.xml><?xml version="1.0" encoding="utf-8"?>
+<p:sld xmlns:a="http://schemas.openxmlformats.org/drawingml/2006/main" xmlns:r="http://schemas.openxmlformats.org/officeDocument/2006/relationships" xmlns:p="http://schemas.openxmlformats.org/presentationml/2006/main">
+  <p:cSld>
+    <p:spTree>
+      <p:nvGrpSpPr>
+        <p:cNvPr id="1" name=""/>
+        <p:cNvGrpSpPr/>
+        <p:nvPr/>
+      </p:nvGrpSpPr>
+      <p:grpSpPr>
+        <a:xfrm>
+          <a:off x="0" y="0"/>
+          <a:ext cx="0" cy="0"/>
+          <a:chOff x="0" y="0"/>
+          <a:chExt cx="0" cy="0"/>
+        </a:xfrm>
+      </p:grpSpPr>
+      <p:sp>
+        <p:nvSpPr>
+          <p:cNvPr id="2" name="Title 1">
+            <a:extLst>
+              <a:ext uri="{FF2B5EF4-FFF2-40B4-BE49-F238E27FC236}">
+                <a16:creationId xmlns:a16="http://schemas.microsoft.com/office/drawing/2014/main" id="{A6BF37F2-5E51-EBE6-FB74-03ECD1F0CB05}"/>
+              </a:ext>
+            </a:extLst>
+          </p:cNvPr>
+          <p:cNvSpPr>
+            <a:spLocks noGrp="1"/>
+          </p:cNvSpPr>
+          <p:nvPr>
+            <p:ph type="title"/>
+          </p:nvPr>
+        </p:nvSpPr>
+        <p:spPr>
+          <a:xfrm>
+            <a:off x="468489" y="434446"/>
+            <a:ext cx="11205668" cy="667808"/>
+          </a:xfrm>
+        </p:spPr>
+        <p:txBody>
+          <a:bodyPr anchor="b">
+            <a:normAutofit/>
+          </a:bodyPr>
+          <a:lstStyle>
+            <a:lvl1pPr>
+              <a:defRPr sz="3200" b="1">
+                <a:solidFill>
+                  <a:srgbClr val="005596"/>
+                </a:solidFill>
+                <a:latin typeface="Poppins" pitchFamily="2" charset="77"/>
+                <a:cs typeface="Poppins" pitchFamily="2" charset="77"/>
+              </a:defRPr>
+            </a:lvl1pPr>
+          </a:lstStyle>
+          <a:p>
+            <a:r>
               <a:t>Platform &amp; Delivery Recommendations</a:t>
             </a:r>
           </a:p>
@@ -9832,7 +10368,7 @@
 </p:sld>
 </file>
 
-<file path=ppt/slides/slide7.xml><?xml version="1.0" encoding="utf-8"?>
+<file path=ppt/slides/slide8.xml><?xml version="1.0" encoding="utf-8"?>
 <p:sld xmlns:a="http://schemas.openxmlformats.org/drawingml/2006/main" xmlns:r="http://schemas.openxmlformats.org/officeDocument/2006/relationships" xmlns:p="http://schemas.openxmlformats.org/presentationml/2006/main">
   <p:cSld>
     <p:spTree>
@@ -11849,6 +12385,15 @@
 </file>
 
 <file path=customXml/item1.xml><?xml version="1.0" encoding="utf-8"?>
+<?mso-contentType ?>
+<FormTemplates xmlns="http://schemas.microsoft.com/sharepoint/v3/contenttype/forms">
+  <Display>DocumentLibraryForm</Display>
+  <Edit>DocumentLibraryForm</Edit>
+  <New>DocumentLibraryForm</New>
+</FormTemplates>
+</file>
+
+<file path=customXml/item2.xml><?xml version="1.0" encoding="utf-8"?>
 <ct:contentTypeSchema xmlns:ct="http://schemas.microsoft.com/office/2006/metadata/contentType" xmlns:ma="http://schemas.microsoft.com/office/2006/metadata/properties/metaAttributes" ct:_="" ma:_="" ma:contentTypeName="Document" ma:contentTypeID="0x01010054B57B89F6F46A48A164DF00BA50A51C" ma:contentTypeVersion="17" ma:contentTypeDescription="Create a new document." ma:contentTypeScope="" ma:versionID="13914a03fbecc1e726daa6b41488eaea">
   <xsd:schema xmlns:xsd="http://www.w3.org/2001/XMLSchema" xmlns:xs="http://www.w3.org/2001/XMLSchema" xmlns:p="http://schemas.microsoft.com/office/2006/metadata/properties" xmlns:ns2="ee986c11-8469-4444-b797-303b6bf690a1" xmlns:ns3="8853d289-f393-46fe-9750-79d7fbe372e2" targetNamespace="http://schemas.microsoft.com/office/2006/metadata/properties" ma:root="true" ma:fieldsID="5a9789bd531938f65d533029cfbd27e4" ns2:_="" ns3:_="">
     <xsd:import namespace="ee986c11-8469-4444-b797-303b6bf690a1"/>
@@ -12095,15 +12640,6 @@
 </ct:contentTypeSchema>
 </file>
 
-<file path=customXml/item2.xml><?xml version="1.0" encoding="utf-8"?>
-<?mso-contentType ?>
-<FormTemplates xmlns="http://schemas.microsoft.com/sharepoint/v3/contenttype/forms">
-  <Display>DocumentLibraryForm</Display>
-  <Edit>DocumentLibraryForm</Edit>
-  <New>DocumentLibraryForm</New>
-</FormTemplates>
-</file>
-
 <file path=customXml/item3.xml><?xml version="1.0" encoding="utf-8"?>
 <p:properties xmlns:p="http://schemas.microsoft.com/office/2006/metadata/properties" xmlns:xsi="http://www.w3.org/2001/XMLSchema-instance" xmlns:pc="http://schemas.microsoft.com/office/infopath/2007/PartnerControls">
   <documentManagement>
@@ -12124,6 +12660,14 @@
 </file>
 
 <file path=customXml/itemProps1.xml><?xml version="1.0" encoding="utf-8"?>
+<ds:datastoreItem xmlns:ds="http://schemas.openxmlformats.org/officeDocument/2006/customXml" ds:itemID="{7108B0CD-7339-4C7A-82F7-014288485001}">
+  <ds:schemaRefs>
+    <ds:schemaRef ds:uri="http://schemas.microsoft.com/sharepoint/v3/contenttype/forms"/>
+  </ds:schemaRefs>
+</ds:datastoreItem>
+</file>
+
+<file path=customXml/itemProps2.xml><?xml version="1.0" encoding="utf-8"?>
 <ds:datastoreItem xmlns:ds="http://schemas.openxmlformats.org/officeDocument/2006/customXml" ds:itemID="{847836F6-29DF-4BE0-A3F5-8AE5D448B767}">
   <ds:schemaRefs>
     <ds:schemaRef ds:uri="http://schemas.microsoft.com/office/2006/metadata/contentType"/>
@@ -12142,27 +12686,19 @@
 </ds:datastoreItem>
 </file>
 
-<file path=customXml/itemProps2.xml><?xml version="1.0" encoding="utf-8"?>
-<ds:datastoreItem xmlns:ds="http://schemas.openxmlformats.org/officeDocument/2006/customXml" ds:itemID="{7108B0CD-7339-4C7A-82F7-014288485001}">
-  <ds:schemaRefs>
-    <ds:schemaRef ds:uri="http://schemas.microsoft.com/sharepoint/v3/contenttype/forms"/>
-  </ds:schemaRefs>
-</ds:datastoreItem>
-</file>
-
 <file path=customXml/itemProps3.xml><?xml version="1.0" encoding="utf-8"?>
 <ds:datastoreItem xmlns:ds="http://schemas.openxmlformats.org/officeDocument/2006/customXml" ds:itemID="{512423F8-1E51-4C77-9BE7-BB24B6F8B93A}">
   <ds:schemaRefs>
+    <ds:schemaRef ds:uri="http://schemas.microsoft.com/office/2006/metadata/properties"/>
     <ds:schemaRef ds:uri="http://purl.org/dc/terms/"/>
+    <ds:schemaRef ds:uri="http://schemas.microsoft.com/office/infopath/2007/PartnerControls"/>
+    <ds:schemaRef ds:uri="http://www.w3.org/XML/1998/namespace"/>
+    <ds:schemaRef ds:uri="http://schemas.microsoft.com/office/2006/documentManagement/types"/>
+    <ds:schemaRef ds:uri="ee986c11-8469-4444-b797-303b6bf690a1"/>
     <ds:schemaRef ds:uri="http://purl.org/dc/elements/1.1/"/>
+    <ds:schemaRef ds:uri="http://purl.org/dc/dcmitype/"/>
+    <ds:schemaRef ds:uri="http://schemas.openxmlformats.org/package/2006/metadata/core-properties"/>
     <ds:schemaRef ds:uri="8853d289-f393-46fe-9750-79d7fbe372e2"/>
-    <ds:schemaRef ds:uri="http://schemas.microsoft.com/office/2006/documentManagement/types"/>
-    <ds:schemaRef ds:uri="http://purl.org/dc/dcmitype/"/>
-    <ds:schemaRef ds:uri="http://schemas.microsoft.com/office/2006/metadata/properties"/>
-    <ds:schemaRef ds:uri="http://schemas.openxmlformats.org/package/2006/metadata/core-properties"/>
-    <ds:schemaRef ds:uri="http://schemas.microsoft.com/office/infopath/2007/PartnerControls"/>
-    <ds:schemaRef ds:uri="ee986c11-8469-4444-b797-303b6bf690a1"/>
-    <ds:schemaRef ds:uri="http://www.w3.org/XML/1998/namespace"/>
   </ds:schemaRefs>
 </ds:datastoreItem>
 </file>
</xml_diff>